<commit_message>
Align 2026 Homework 3 with Weeks 9-10
Rewrite the assignment and solutions to cover normal probabilities, the CLT, confidence intervals, sample sizes, and one-sample hypothesis tests. Replace obsolete CSV tables, add references, and refresh HTML/PDF outputs. Hide Homework 3 downloads pending review and release.
</commit_message>
<xml_diff>
--- a/docs/lecture_slides/Week 9/2026/Week9_Lecture19_Slides_10_19_2026.pptx
+++ b/docs/lecture_slides/Week 9/2026/Week9_Lecture19_Slides_10_19_2026.pptx
@@ -279,7 +279,7 @@
           <a:p>
             <a:fld id="{06882561-BD16-4A95-ACA1-5204E478F2FE}" type="datetimeFigureOut">
               <a:rPr lang="en-US" smtClean="0"/>
-              <a:t>10/18/2026</a:t>
+              <a:t>10/19/2026</a:t>
             </a:fld>
             <a:endParaRPr lang="en-US"/>
           </a:p>
@@ -477,7 +477,7 @@
           <a:p>
             <a:fld id="{06882561-BD16-4A95-ACA1-5204E478F2FE}" type="datetimeFigureOut">
               <a:rPr lang="en-US" smtClean="0"/>
-              <a:t>10/18/2026</a:t>
+              <a:t>10/19/2026</a:t>
             </a:fld>
             <a:endParaRPr lang="en-US"/>
           </a:p>
@@ -685,7 +685,7 @@
           <a:p>
             <a:fld id="{06882561-BD16-4A95-ACA1-5204E478F2FE}" type="datetimeFigureOut">
               <a:rPr lang="en-US" smtClean="0"/>
-              <a:t>10/18/2026</a:t>
+              <a:t>10/19/2026</a:t>
             </a:fld>
             <a:endParaRPr lang="en-US"/>
           </a:p>
@@ -883,7 +883,7 @@
           <a:p>
             <a:fld id="{06882561-BD16-4A95-ACA1-5204E478F2FE}" type="datetimeFigureOut">
               <a:rPr lang="en-US" smtClean="0"/>
-              <a:t>10/18/2026</a:t>
+              <a:t>10/19/2026</a:t>
             </a:fld>
             <a:endParaRPr lang="en-US"/>
           </a:p>
@@ -1158,7 +1158,7 @@
           <a:p>
             <a:fld id="{06882561-BD16-4A95-ACA1-5204E478F2FE}" type="datetimeFigureOut">
               <a:rPr lang="en-US" smtClean="0"/>
-              <a:t>10/18/2026</a:t>
+              <a:t>10/19/2026</a:t>
             </a:fld>
             <a:endParaRPr lang="en-US"/>
           </a:p>
@@ -1423,7 +1423,7 @@
           <a:p>
             <a:fld id="{06882561-BD16-4A95-ACA1-5204E478F2FE}" type="datetimeFigureOut">
               <a:rPr lang="en-US" smtClean="0"/>
-              <a:t>10/18/2026</a:t>
+              <a:t>10/19/2026</a:t>
             </a:fld>
             <a:endParaRPr lang="en-US"/>
           </a:p>
@@ -1835,7 +1835,7 @@
           <a:p>
             <a:fld id="{06882561-BD16-4A95-ACA1-5204E478F2FE}" type="datetimeFigureOut">
               <a:rPr lang="en-US" smtClean="0"/>
-              <a:t>10/18/2026</a:t>
+              <a:t>10/19/2026</a:t>
             </a:fld>
             <a:endParaRPr lang="en-US"/>
           </a:p>
@@ -1976,7 +1976,7 @@
           <a:p>
             <a:fld id="{06882561-BD16-4A95-ACA1-5204E478F2FE}" type="datetimeFigureOut">
               <a:rPr lang="en-US" smtClean="0"/>
-              <a:t>10/18/2026</a:t>
+              <a:t>10/19/2026</a:t>
             </a:fld>
             <a:endParaRPr lang="en-US"/>
           </a:p>
@@ -2089,7 +2089,7 @@
           <a:p>
             <a:fld id="{06882561-BD16-4A95-ACA1-5204E478F2FE}" type="datetimeFigureOut">
               <a:rPr lang="en-US" smtClean="0"/>
-              <a:t>10/18/2026</a:t>
+              <a:t>10/19/2026</a:t>
             </a:fld>
             <a:endParaRPr lang="en-US"/>
           </a:p>
@@ -2400,7 +2400,7 @@
           <a:p>
             <a:fld id="{06882561-BD16-4A95-ACA1-5204E478F2FE}" type="datetimeFigureOut">
               <a:rPr lang="en-US" smtClean="0"/>
-              <a:t>10/18/2026</a:t>
+              <a:t>10/19/2026</a:t>
             </a:fld>
             <a:endParaRPr lang="en-US"/>
           </a:p>
@@ -2688,7 +2688,7 @@
           <a:p>
             <a:fld id="{06882561-BD16-4A95-ACA1-5204E478F2FE}" type="datetimeFigureOut">
               <a:rPr lang="en-US" smtClean="0"/>
-              <a:t>10/18/2026</a:t>
+              <a:t>10/19/2026</a:t>
             </a:fld>
             <a:endParaRPr lang="en-US"/>
           </a:p>
@@ -2929,7 +2929,7 @@
           <a:p>
             <a:fld id="{06882561-BD16-4A95-ACA1-5204E478F2FE}" type="datetimeFigureOut">
               <a:rPr lang="en-US" smtClean="0"/>
-              <a:t>10/18/2026</a:t>
+              <a:t>10/19/2026</a:t>
             </a:fld>
             <a:endParaRPr lang="en-US"/>
           </a:p>
@@ -9583,7 +9583,7 @@
             </a:r>
             <a:r>
               <a:rPr lang="en-US" b="1"/>
-              <a:t>For a continuous random variable, what is P(X = c)?</a:t>
+              <a:t>What is the standard error of p̂?</a:t>
             </a:r>
             <a:endParaRPr lang="en-US" b="1" dirty="0"/>
           </a:p>
@@ -9620,98 +9620,7 @@
                   <a:srgbClr val="C00000"/>
                 </a:solidFill>
               </a:rPr>
-              <a:t>0: a single value has no width, so it has no area under the curve.</a:t>
-            </a:r>
-            <a:endParaRPr lang="en-US" sz="1600" dirty="0">
-              <a:solidFill>
-                <a:srgbClr val="C00000"/>
-              </a:solidFill>
-            </a:endParaRPr>
-          </a:p>
-        </p:txBody>
-      </p:sp>
-      <p:sp>
-        <p:nvSpPr>
-          <p:cNvPr id="9" name="Question 4"/>
-          <p:cNvSpPr/>
-          <p:nvPr/>
-        </p:nvSpPr>
-        <p:spPr>
-          <a:xfrm>
-            <a:off x="838200" y="5005688"/>
-            <a:ext cx="10515600" cy="1230000"/>
-          </a:xfrm>
-          <a:prstGeom prst="roundRect">
-            <a:avLst>
-              <a:gd name="adj" fmla="val 4000"/>
-            </a:avLst>
-          </a:prstGeom>
-          <a:solidFill>
-            <a:srgbClr val="F2F6FC"/>
-          </a:solidFill>
-          <a:ln w="19050">
-            <a:solidFill>
-              <a:schemeClr val="accent1"/>
-            </a:solidFill>
-          </a:ln>
-        </p:spPr>
-        <p:txBody>
-          <a:bodyPr lIns="228600" tIns="182880" rIns="228600" bIns="91440" anchor="t">
-            <a:noAutofit/>
-          </a:bodyPr>
-          <a:lstStyle/>
-          <a:p>
-            <a:pPr marL="0" indent="0">
-              <a:buNone/>
-            </a:pPr>
-            <a:r>
-              <a:rPr lang="en-US" b="1">
-                <a:solidFill>
-                  <a:srgbClr val="C00000"/>
-                </a:solidFill>
-              </a:rPr>
-              <a:t>4   </a:t>
-            </a:r>
-            <a:r>
-              <a:rPr lang="en-US" b="1"/>
-              <a:t>What is the standard normal distribution?</a:t>
-            </a:r>
-            <a:endParaRPr lang="en-US" b="1" dirty="0"/>
-          </a:p>
-        </p:txBody>
-      </p:sp>
-      <p:sp>
-        <p:nvSpPr>
-          <p:cNvPr id="10" name="Answer 4"/>
-          <p:cNvSpPr txBox="1"/>
-          <p:nvPr/>
-        </p:nvSpPr>
-        <p:spPr>
-          <a:xfrm>
-            <a:off x="1066800" y="5585688"/>
-            <a:ext cx="10058400" cy="589280"/>
-          </a:xfrm>
-          <a:prstGeom prst="rect">
-            <a:avLst/>
-          </a:prstGeom>
-          <a:noFill/>
-        </p:spPr>
-        <p:txBody>
-          <a:bodyPr wrap="square" lIns="0" tIns="0" rIns="0" bIns="0">
-            <a:noAutofit/>
-          </a:bodyPr>
-          <a:lstStyle/>
-          <a:p>
-            <a:pPr marL="0" indent="0">
-              <a:buNone/>
-            </a:pPr>
-            <a:r>
-              <a:rPr lang="en-US" sz="1600">
-                <a:solidFill>
-                  <a:srgbClr val="C00000"/>
-                </a:solidFill>
-              </a:rPr>
-              <a:t>N(0, 1): the normal distribution of z-scores, with mean 0 and standard deviation 1.</a:t>
+              <a:t>√(p(1 − p) / n):  how much p̂ varies from sample to sample.</a:t>
             </a:r>
             <a:endParaRPr lang="en-US" sz="1600" dirty="0">
               <a:solidFill>
@@ -10020,96 +9929,6 @@
                                         </p:cTn>
                                         <p:tgtEl>
                                           <p:spTgt spid="8"/>
-                                        </p:tgtEl>
-                                        <p:attrNameLst>
-                                          <p:attrName>style.visibility</p:attrName>
-                                        </p:attrNameLst>
-                                      </p:cBhvr>
-                                      <p:to>
-                                        <p:strVal val="visible"/>
-                                      </p:to>
-                                    </p:set>
-                                  </p:childTnLst>
-                                </p:cTn>
-                              </p:par>
-                            </p:childTnLst>
-                          </p:cTn>
-                        </p:par>
-                      </p:childTnLst>
-                    </p:cTn>
-                  </p:par>
-                  <p:par>
-                    <p:cTn id="27" fill="hold">
-                      <p:stCondLst>
-                        <p:cond delay="indefinite"/>
-                      </p:stCondLst>
-                      <p:childTnLst>
-                        <p:par>
-                          <p:cTn id="28" fill="hold">
-                            <p:stCondLst>
-                              <p:cond delay="0"/>
-                            </p:stCondLst>
-                            <p:childTnLst>
-                              <p:par>
-                                <p:cTn id="29" presetID="1" presetClass="entr" presetSubtype="0" fill="hold" nodeType="clickEffect">
-                                  <p:stCondLst>
-                                    <p:cond delay="0"/>
-                                  </p:stCondLst>
-                                  <p:childTnLst>
-                                    <p:set>
-                                      <p:cBhvr>
-                                        <p:cTn id="30" dur="1" fill="hold">
-                                          <p:stCondLst>
-                                            <p:cond delay="0"/>
-                                          </p:stCondLst>
-                                        </p:cTn>
-                                        <p:tgtEl>
-                                          <p:spTgt spid="9"/>
-                                        </p:tgtEl>
-                                        <p:attrNameLst>
-                                          <p:attrName>style.visibility</p:attrName>
-                                        </p:attrNameLst>
-                                      </p:cBhvr>
-                                      <p:to>
-                                        <p:strVal val="visible"/>
-                                      </p:to>
-                                    </p:set>
-                                  </p:childTnLst>
-                                </p:cTn>
-                              </p:par>
-                            </p:childTnLst>
-                          </p:cTn>
-                        </p:par>
-                      </p:childTnLst>
-                    </p:cTn>
-                  </p:par>
-                  <p:par>
-                    <p:cTn id="31" fill="hold">
-                      <p:stCondLst>
-                        <p:cond delay="indefinite"/>
-                      </p:stCondLst>
-                      <p:childTnLst>
-                        <p:par>
-                          <p:cTn id="32" fill="hold">
-                            <p:stCondLst>
-                              <p:cond delay="0"/>
-                            </p:stCondLst>
-                            <p:childTnLst>
-                              <p:par>
-                                <p:cTn id="33" presetID="1" presetClass="entr" presetSubtype="0" fill="hold" nodeType="clickEffect">
-                                  <p:stCondLst>
-                                    <p:cond delay="0"/>
-                                  </p:stCondLst>
-                                  <p:childTnLst>
-                                    <p:set>
-                                      <p:cBhvr>
-                                        <p:cTn id="34" dur="1" fill="hold">
-                                          <p:stCondLst>
-                                            <p:cond delay="0"/>
-                                          </p:stCondLst>
-                                        </p:cTn>
-                                        <p:tgtEl>
-                                          <p:spTgt spid="10"/>
                                         </p:tgtEl>
                                         <p:attrNameLst>
                                           <p:attrName>style.visibility</p:attrName>

</xml_diff>